<commit_message>
Formatting changes in the PPT
</commit_message>
<xml_diff>
--- a/attachment/Certificate.pptx
+++ b/attachment/Certificate.pptx
@@ -15,7 +15,7 @@
       <p:regular r:id="rId3"/>
     </p:embeddedFont>
     <p:embeddedFont>
-      <p:font typeface="DM Serif Display" panose="020F0502020204030204" pitchFamily="2" charset="0"/>
+      <p:font typeface="DM Serif Display" pitchFamily="2" charset="0"/>
       <p:regular r:id="rId4"/>
     </p:embeddedFont>
     <p:embeddedFont>
@@ -4749,7 +4749,7 @@
               </a:lnSpc>
             </a:pPr>
             <a:r>
-              <a:rPr lang="en-US" sz="2036" b="1" i="1" spc="437">
+              <a:rPr lang="en-US" sz="2036" b="1" i="1" spc="437" dirty="0">
                 <a:solidFill>
                   <a:srgbClr val="000000"/>
                 </a:solidFill>
@@ -4790,7 +4790,7 @@
               </a:lnSpc>
             </a:pPr>
             <a:r>
-              <a:rPr lang="en-US" sz="4998" spc="499">
+              <a:rPr lang="en-US" sz="4998" spc="499" dirty="0">
                 <a:solidFill>
                   <a:srgbClr val="0025CC"/>
                 </a:solidFill>
@@ -4883,15 +4883,15 @@
         </p:nvSpPr>
         <p:spPr>
           <a:xfrm>
-            <a:off x="6685292" y="3928125"/>
-            <a:ext cx="4917416" cy="397281"/>
+            <a:off x="6591300" y="3927976"/>
+            <a:ext cx="5105400" cy="402354"/>
           </a:xfrm>
           <a:prstGeom prst="rect">
             <a:avLst/>
           </a:prstGeom>
         </p:spPr>
         <p:txBody>
-          <a:bodyPr lIns="0" tIns="0" rIns="0" bIns="0" rtlCol="0" anchor="t">
+          <a:bodyPr wrap="square" lIns="0" tIns="0" rIns="0" bIns="0" rtlCol="0" anchor="t">
             <a:spAutoFit/>
           </a:bodyPr>
           <a:lstStyle/>
@@ -4905,7 +4905,7 @@
               </a:spcBef>
             </a:pPr>
             <a:r>
-              <a:rPr lang="en-US" sz="2959" b="1" spc="-88">
+              <a:rPr lang="en-US" sz="2959" b="1" spc="-88" dirty="0">
                 <a:solidFill>
                   <a:srgbClr val="000000"/>
                 </a:solidFill>
@@ -4927,7 +4927,7 @@
         </p:nvSpPr>
         <p:spPr>
           <a:xfrm>
-            <a:off x="4572740" y="3146339"/>
+            <a:off x="4646475" y="3146339"/>
             <a:ext cx="8995047" cy="1254959"/>
           </a:xfrm>
           <a:prstGeom prst="rect">

</xml_diff>

<commit_message>
Formatting changes in PPT
</commit_message>
<xml_diff>
--- a/attachment/Certificate.pptx
+++ b/attachment/Certificate.pptx
@@ -4892,8 +4892,8 @@
         </p:nvSpPr>
         <p:spPr>
           <a:xfrm>
-            <a:off x="1185510" y="8482796"/>
-            <a:ext cx="2130663" cy="616949"/>
+            <a:off x="928001" y="8482796"/>
+            <a:ext cx="2566727" cy="616949"/>
           </a:xfrm>
           <a:prstGeom prst="rect">
             <a:avLst/>
@@ -4982,8 +4982,8 @@
         </p:nvSpPr>
         <p:spPr>
           <a:xfrm>
-            <a:off x="4272418" y="8482796"/>
-            <a:ext cx="2412874" cy="617157"/>
+            <a:off x="3927553" y="8482796"/>
+            <a:ext cx="2820953" cy="617157"/>
           </a:xfrm>
           <a:prstGeom prst="rect">
             <a:avLst/>
@@ -5126,8 +5126,8 @@
         </p:nvSpPr>
         <p:spPr>
           <a:xfrm>
-            <a:off x="11135212" y="8482796"/>
-            <a:ext cx="1971188" cy="616949"/>
+            <a:off x="11039024" y="8482796"/>
+            <a:ext cx="2275627" cy="616949"/>
           </a:xfrm>
           <a:prstGeom prst="rect">
             <a:avLst/>
@@ -5207,8 +5207,8 @@
         </p:nvSpPr>
         <p:spPr>
           <a:xfrm>
-            <a:off x="14174365" y="8482796"/>
-            <a:ext cx="1973059" cy="616949"/>
+            <a:off x="13934001" y="8482796"/>
+            <a:ext cx="2394841" cy="616949"/>
           </a:xfrm>
           <a:prstGeom prst="rect">
             <a:avLst/>

</xml_diff>

<commit_message>
Small change in formatting
</commit_message>
<xml_diff>
--- a/attachment/Certificate.pptx
+++ b/attachment/Certificate.pptx
@@ -4763,15 +4763,15 @@
         </p:nvSpPr>
         <p:spPr>
           <a:xfrm>
-            <a:off x="16147424" y="1134991"/>
-            <a:ext cx="1312643" cy="174412"/>
+            <a:off x="16029758" y="1135337"/>
+            <a:ext cx="1508068" cy="168701"/>
           </a:xfrm>
           <a:prstGeom prst="rect">
             <a:avLst/>
           </a:prstGeom>
         </p:spPr>
         <p:txBody>
-          <a:bodyPr lIns="0" tIns="0" rIns="0" bIns="0" rtlCol="0" anchor="t">
+          <a:bodyPr wrap="square" lIns="0" tIns="0" rIns="0" bIns="0" rtlCol="0" anchor="t">
             <a:spAutoFit/>
           </a:bodyPr>
           <a:lstStyle/>
@@ -4782,7 +4782,7 @@
               </a:lnSpc>
             </a:pPr>
             <a:r>
-              <a:rPr lang="en-US" sz="1284" spc="128">
+              <a:rPr lang="en-US" sz="1284" spc="128" dirty="0">
                 <a:solidFill>
                   <a:srgbClr val="7A2F00"/>
                 </a:solidFill>

</xml_diff>